<commit_message>
Lit review update, agentic-RL extension sketch, deck script revision
- lit-review: adds Wang, Li & Chen (2025) and Itzhak, Belinkov & Stanovsky
  (2025) to the post-training category, plus a revised niche assessment.
- extension-agentic-rl: follow-on sketch on why models look like maximizers
  in agentic evals but not in the lottery instruments (refit numbers checked
  against results/profile_refit).
- 10-minute deck: "most of" framing for the SFT step, revised speaker notes;
  all figures quoted are model-free and match the Phase 3 data.

Co-Authored-By: Claude Opus 5.5 <noreply@anthropic.com>
</commit_message>
<xml_diff>
--- a/briefings/phase3-findings-10min.pptx
+++ b/briefings/phase3-findings-10min.pptx
@@ -292,7 +292,7 @@
           <a:p>
             <a:r>
               <a:rPr lang="en-US" dirty="0"/>
-              <a:t>Take a second and answer that one yourself. A sure eighty-six dollars, or a forty-three percent shot at two hundred and ten. The gamble pays more on average, about ninety dollars, and leaves you with nothing more than half the time. Which one you pick says something about how you handle risk, and economists have been asking people questions like this since the nineteen seventies. We asked AI models thousands of them, then traced the answers back through each model's training history. Here is where I am going. Almost everything about how these models handle money arrives at one training step, and it is the first and simplest one. Let me start with why anyone should care.</a:t>
+              <a:t>Take a second and answer that one yourself. A sure eighty-six dollars, or a forty-three percent shot at two hundred and ten. The gamble pays more on average, about ninety dollars, and leaves you with nothing more than half the time. Which one you pick says something about how you handle risk, and economists have been asking people questions like this since the nineteen seventies. We asked AI models thousands of them, then traced the answers back through each model's training history. Here is where I am going. Most of how these models handle money arrives at one training step, and it is the first and simplest one. Let me start with why anyone should care.</a:t>
             </a:r>
           </a:p>
         </p:txBody>
@@ -379,7 +379,7 @@
           <a:p>
             <a:r>
               <a:rPr lang="en-US" dirty="0"/>
-              <a:t>Three follow-ups for the fall. The first matters most; it tests this phase's ceiling. Every answer here had to be one letter, produced immediately. Give it room to work the arithmetic out first, and we learn whether it cannot compute or simply does not. Second, make the stakes real. Nothing was at stake here. Denominating payoffs in computing time the model actually spends turns a hypothetical into a real incentive, which is what makes the method work on people. Third, the same machinery measures social preferences, so we ask whether a model cooperates more with a counterpart it takes for its own kind. The money personality arrives at one training step, and that is where to look. Thank you.</a:t>
+              <a:t>Three follow-ups for the fall. The first matters most; it tests this phase's ceiling. Every answer here had to be one letter, produced immediately. Give it room to work the arithmetic out first, and we learn whether it cannot compute or simply does not. Second, make the stakes real. Nothing was at stake here. Denominating payoffs in computing time the model actually spends turns a hypothetical into a real incentive, which is what makes the method work on people. Third, the same machinery measures social preferences, so we ask whether a model cooperates more with a counterpart it takes for its own kind. Most of the money personality arrives at one training step, and that is where to start looking. Thank you.</a:t>
             </a:r>
           </a:p>
         </p:txBody>
@@ -466,7 +466,7 @@
           <a:p>
             <a:r>
               <a:rPr lang="en-US" dirty="0"/>
-              <a:t>Why check what an AI prefers? Three reasons. These systems already sit inside real money decisions. They draft budgets, screen loan files, price contracts, and advise people on retirement accounts. Every one is a choice under uncertainty, and a system that quietly prefers a sure thing to a better bet tilts every recommendation. Second, we do not have to ask a model what it values. Economists spent fifty years reading preferences out of what people choose rather than what they say about themselves, and that method transfers to a model unchanged. Third, and this is my gap, everybody tests the finished chatbot and stops. Nobody asks which manufacturing step put the behavior there. Here is how we opened the box.</a:t>
+              <a:t>Why check what an AI prefers? Three reasons. These systems already sit inside real money decisions. They draft budgets, screen loan files, price contracts, and advise people on retirement accounts. Every one is a choice under uncertainty, and a system that quietly prefers a sure thing to a better bet tilts every recommendation. Second, we do not have to ask a model what it values. Economists spent fifty years reading preferences out of what people choose rather than what they say about themselves, and that method transfers to a model unchanged. Third, and this is my gap, most work tests the finished chatbot, and the few studies that compare it with the raw model skip every step in between. Nobody asks which manufacturing step put the behavior there. Here is how we opened the box.</a:t>
             </a:r>
           </a:p>
         </p:txBody>
@@ -640,7 +640,7 @@
           <a:p>
             <a:r>
               <a:rPr lang="en-US" dirty="0"/>
-              <a:t>Here is the free money result, and this is where the talk turns. Before a model is trained to act like an assistant it is a base model, which means it has read a huge chunk of the internet and nothing else. It answers A or B with total confidence. Look at the three grey bars. The dotted red line down the middle is a coin flip. Offer these base models a sure fifty against a sure seventy, no gambling involved, and OLMo takes the seventy fifty-five and a half percent of the time. Llama, sixty-two point three. Qwen, sixty-three point nine. Just over half the time. The purple bar on top is Claude Haiku, a finished assistant, at a hundred percent. Somebody always asks whether the answers are just random. This check settles it. A base model does not have strange preferences. It has no usable preferences at all. So whatever we measure later was installed by training rather than inherited from the internet. Installed when?</a:t>
+              <a:t>Here is the free money result, and this is where the talk turns. Before a model is trained to act like an assistant it is a base model, which means it has read a huge chunk of the internet and nothing else. It answers A or B with total confidence. Look at the three grey bars. The dotted red line down the middle is a coin flip. Offer these base models a sure fifty against a sure seventy, no gambling involved, and OLMo takes the seventy fifty-five and a half percent of the time. Llama, sixty-two point three. Qwen, sixty-three point nine. Just over half the time. The purple bar on top is Claude Haiku, a finished assistant, at a hundred percent. Somebody always asks whether the answers are just random. This check settles it. A base model does not have strange preferences. It has no usable preferences at all. So whatever we measure later only becomes visible through training. Whether training builds it or brings out something the model absorbed from the internet, these answers cannot tell us. What we can ask is when it shows up.</a:t>
             </a:r>
           </a:p>
         </p:txBody>
@@ -727,7 +727,7 @@
           <a:p>
             <a:r>
               <a:rPr lang="en-US" dirty="0"/>
-              <a:t>This slide answers it, and it is the finding. OLMo-2 is the one family that publishes a snapshot after every training step, so we asked identical questions at four points in one model's life. Along the bottom is that life story: pre-trained base, after supervised fine-tuning, after preference training, finished assistant. Supervised fine-tuning is the first step where humans show the model examples of being a helpful assistant. Look at the purple line, free money accuracy. It jumps from fifty-five and a half to seventy-five point six at that first step, then only crawls to eighty-eight point two and eighty-nine point six. The grey line below is extra gambling when a bet gets called a loss: nine point nine, twenty-four point three, thirty-one point eight, thirty-four point nine. Same shape. The whole personality appears inside that shaded band on the left. Human feedback enters at the later stages, and those are the ones everyone blames. Why does the step matter? That is where you would audit. One more wrinkle first.</a:t>
+              <a:t>This slide answers it, and it is the finding. OLMo-2 is the one family that publishes a snapshot after every training step, so we asked identical questions at four points in one model's life. Along the bottom is that life story: pre-trained base, after supervised fine-tuning, after preference training, finished assistant. Supervised fine-tuning is the first step where humans show the model examples of being a helpful assistant. Look at the purple line, free money accuracy. It jumps from fifty-five and a half to seventy-five point six at that first step, then keeps climbing more slowly, to eighty-eight point two and eighty-nine point six. The grey line below is extra gambling when a bet gets called a loss: nine point nine, twenty-four point three, thirty-one point eight, thirty-four point nine. Same shape. About three fifths of the change on both lines happens inside that shaded band on the left, and it is the only step where our estimate of the model’s preferences moves. Human feedback enters at the later stages, and those are the ones everyone blames. They keep pushing in the same direction, but they arrive to find the pattern already there. Why does the step matter? That is where you would audit. One more wrinkle first.</a:t>
             </a:r>
           </a:p>
         </p:txBody>
@@ -1075,7 +1075,7 @@
           <a:p>
             <a:r>
               <a:rPr lang="en-US" dirty="0"/>
-              <a:t>Four takeaways, in the order they would change what somebody does Monday. One, the framing bias belongs to a training recipe rather than to AI as a technology, so a vulnerability documented on one model tells a procurement officer nothing reliable about the model being deployed. Two, look earlier than people do. If the behavior is installed at supervised fine-tuning, that data and the checkpoint right after it are where you inspect it, and that is not where attention goes. Three, check that the subject is awake, the way a survey reports its response rate. Four, instructions do not override training. Telling a model to maximize expected value moved it about three points. Here is where I take it next.</a:t>
+              <a:t>Four takeaways, in the order they would change what somebody does Monday. One, the framing bias belongs to a training recipe rather than to AI as a technology, so a vulnerability documented on one model tells a procurement officer nothing reliable about the model being deployed. Two, look earlier than people do. The checkpoint right after supervised fine-tuning is the earliest place the behavior can be measured, and most of it is already there. Governance attention goes to the later preference stage, which starts late. Three, check that the subject is awake, the way a survey reports its response rate. Four, instructions do not override training. Telling a model to maximize expected value moved it about three points. Here is where I take it next.</a:t>
             </a:r>
           </a:p>
         </p:txBody>
@@ -1613,7 +1613,7 @@
                 <a:ea typeface="Georgia" pitchFamily="34" charset="-122"/>
                 <a:cs typeface="Georgia" pitchFamily="34" charset="-120"/>
               </a:rPr>
-              <a:t>The money personality arrives at one training step.</a:t>
+              <a:t>Most of the money personality arrives at one training step.</a:t>
             </a:r>
             <a:endParaRPr lang="en-US" sz="3400" dirty="0"/>
           </a:p>
@@ -4345,7 +4345,7 @@
                 <a:ea typeface="Georgia" pitchFamily="34" charset="-122"/>
                 <a:cs typeface="Georgia" pitchFamily="34" charset="-120"/>
               </a:rPr>
-              <a:t>Nobody has run the check</a:t>
+              <a:t>No one checks each step</a:t>
             </a:r>
             <a:endParaRPr lang="en-US" sz="2700" dirty="0"/>
           </a:p>
@@ -4387,7 +4387,7 @@
                 <a:ea typeface="Helvetica Neue" pitchFamily="34" charset="-122"/>
                 <a:cs typeface="Helvetica Neue" pitchFamily="34" charset="-120"/>
               </a:rPr>
-              <a:t>Published work tests the finished assistant and stops. That cannot tell you whether a habit came from reading the internet or from the training that came afterward.</a:t>
+              <a:t>Published work tests the finished assistant, or compares it with the raw model. Neither can tell you which training step put a habit there.</a:t>
             </a:r>
             <a:endParaRPr lang="en-US" sz="1700" dirty="0"/>
           </a:p>
@@ -6699,7 +6699,7 @@
                 <a:ea typeface="Helvetica Neue" pitchFamily="34" charset="-122"/>
                 <a:cs typeface="Helvetica Neue" pitchFamily="34" charset="-120"/>
               </a:rPr>
-              <a:t>At supervised fine-tuning, the first and simplest of the assistant-training steps.</a:t>
+              <a:t>Mostly at supervised fine-tuning, the first and simplest of the assistant-training steps.</a:t>
             </a:r>
             <a:endParaRPr lang="en-US" sz="2000" dirty="0"/>
           </a:p>
@@ -10609,7 +10609,7 @@
                 <a:ea typeface="Helvetica Neue" pitchFamily="34" charset="-122"/>
                 <a:cs typeface="Helvetica Neue" pitchFamily="34" charset="-120"/>
               </a:rPr>
-              <a:t>If a behavior is installed at supervised fine-tuning, that is where to audit it, rather than at the preference-training stage that receives most of the governance attention.</a:t>
+              <a:t>The checkpoint after supervised fine-tuning is the earliest place a behavior can be measured, and where most of it appears. An audit that starts at preference training starts late.</a:t>
             </a:r>
             <a:endParaRPr lang="en-US" sz="1600" dirty="0"/>
           </a:p>

</xml_diff>